<commit_message>
Second review pass, export choices, and report update
- Review: all 2,366 hidden links on the top-300 topics judged (680 accepted);
  all 3,955 visible Maclaren machine links judged (3,109 kept, 846 rejected).
- Fix: decisions on entries that share a key are no longer skipped as duplicates.
- ai_review next: --top, --work and --visible options.
- Export: --translation KJV|ASV|BBE|WEB (default KJV), PDF copies of handouts
  and teacher's notes, 'Where Christians differ' on one slide and in the
  handout for all-views lessons; one-line view headlines in perspectives.tsv.
- Ratings count after 5 votes. All 44 lessons regenerated in KJV.
- REPORT.md, LESSONS.md, lessons/README.md and COUNTS.md updated.

Co-Authored-By: Claude Opus 5.5 <noreply@anthropic.com>
Claude-Session: https://claude.ai/code/session_012GRcBWdPw5e3Ch8ztZP4Qh
</commit_message>
<xml_diff>
--- a/lessons/output/baptism/baptism-slides.pptx
+++ b/lessons/output/baptism/baptism-slides.pptx
@@ -13,6 +13,7 @@
     <p:sldId id="261" r:id="rId13"/>
     <p:sldId id="262" r:id="rId14"/>
     <p:sldId id="263" r:id="rId15"/>
+    <p:sldId id="264" r:id="rId16"/>
   </p:sldIdLst>
   <p:sldSz cx="12191695" cy="6858000" type="screen4x3"/>
   <p:notesSz cx="6858000" cy="9144000"/>
@@ -674,6 +675,76 @@
           <a:p>
             <a:r>
               <a:t>“by our very profession made in baptism we have renounced sin, and have pledged ourselves to live to God.” — Albert Barnes, Notes on the New Testament, on Romans 6:3</a:t>
+            </a:r>
+          </a:p>
+        </p:txBody>
+      </p:sp>
+      <p:sp>
+        <p:nvSpPr>
+          <p:cNvPr id="4" name="Slide Number Placeholder 3"/>
+          <p:cNvSpPr>
+            <a:spLocks noGrp="1"/>
+          </p:cNvSpPr>
+          <p:nvPr>
+            <p:ph type="sldNum" idx="5" sz="quarter"/>
+          </p:nvPr>
+        </p:nvSpPr>
+        <p:spPr/>
+      </p:sp>
+    </p:spTree>
+  </p:cSld>
+  <p:clrMapOvr>
+    <a:masterClrMapping/>
+  </p:clrMapOvr>
+</p:notes>
+</file>
+
+<file path=ppt/notesSlides/notesSlide4.xml><?xml version="1.0" encoding="utf-8"?>
+<p:notes xmlns:a="http://schemas.openxmlformats.org/drawingml/2006/main" xmlns:p="http://schemas.openxmlformats.org/presentationml/2006/main" xmlns:r="http://schemas.openxmlformats.org/officeDocument/2006/relationships">
+  <p:cSld>
+    <p:spTree>
+      <p:nvGrpSpPr>
+        <p:cNvPr id="1" name=""/>
+        <p:cNvGrpSpPr/>
+        <p:nvPr/>
+      </p:nvGrpSpPr>
+      <p:grpSpPr>
+        <a:xfrm>
+          <a:off x="0" y="0"/>
+          <a:ext cx="0" cy="0"/>
+          <a:chOff x="0" y="0"/>
+          <a:chExt cx="0" cy="0"/>
+        </a:xfrm>
+      </p:grpSpPr>
+      <p:sp>
+        <p:nvSpPr>
+          <p:cNvPr id="2" name="Slide Image Placeholder 1"/>
+          <p:cNvSpPr>
+            <a:spLocks noGrp="1"/>
+          </p:cNvSpPr>
+          <p:nvPr>
+            <p:ph type="sldImg" idx="2"/>
+          </p:nvPr>
+        </p:nvSpPr>
+        <p:spPr/>
+      </p:sp>
+      <p:sp>
+        <p:nvSpPr>
+          <p:cNvPr id="3" name="Notes Placeholder 2"/>
+          <p:cNvSpPr>
+            <a:spLocks noGrp="1"/>
+          </p:cNvSpPr>
+          <p:nvPr>
+            <p:ph type="body" idx="3" sz="quarter"/>
+          </p:nvPr>
+        </p:nvSpPr>
+        <p:spPr/>
+        <p:txBody>
+          <a:bodyPr/>
+          <a:lstStyle/>
+          <a:p>
+            <a:r>
+              <a:t>Christians agree that Jesus commanded baptism, that it is done with water in the name of the Father, Son and Holy Spirit, that it is linked with repentance, faith, forgiveness and union with Christ, and that true baptism is not repeated. They differ on three questions: who should be baptized (believers only, or also the children of believers), how (immersion, or also pouring and sprinkling), and what baptism does (a means through which God gives grace, a sign and seal of his covenant, or an act of obedience that testifies to grace already received). Here are the main views of the five traditions, each described as its own teachers describe it. Sincere, Bible-believing Christians hold each of them.</a:t>
             </a:r>
           </a:p>
         </p:txBody>
@@ -5007,7 +5078,7 @@
                   <a:srgbClr val="222B36"/>
                 </a:solidFill>
               </a:rPr>
-              <a:t>Discuss</a:t>
+              <a:t>Where Christians differ</a:t>
             </a:r>
           </a:p>
         </p:txBody>
@@ -5058,8 +5129,8 @@
         </p:nvSpPr>
         <p:spPr>
           <a:xfrm>
-            <a:off x="640080" y="1554480"/>
-            <a:ext cx="10881360" cy="4572000"/>
+            <a:off x="640080" y="1417320"/>
+            <a:ext cx="10881360" cy="4754880"/>
           </a:xfrm>
           <a:prstGeom prst="rect">
             <a:avLst/>
@@ -5074,70 +5145,116 @@
           <a:p>
             <a:pPr>
               <a:spcAft>
-                <a:spcPts val="1800"/>
+                <a:spcPts val="1200"/>
               </a:spcAft>
             </a:pPr>
             <a:r>
-              <a:rPr sz="2800" b="1" i="0">
+              <a:rPr sz="2000" b="1" i="0">
                 <a:solidFill>
                   <a:srgbClr val="2E5E8C"/>
                 </a:solidFill>
               </a:rPr>
-              <a:t>1.  </a:t>
-            </a:r>
-            <a:r>
-              <a:rPr sz="2800" b="0" i="0">
+              <a:t>Baptist:  </a:t>
+            </a:r>
+            <a:r>
+              <a:rPr sz="2000" b="0" i="0">
                 <a:solidFill>
                   <a:srgbClr val="222B36"/>
                 </a:solidFill>
               </a:rPr>
-              <a:t>What do all Christians agree about baptism, according to today's passages?</a:t>
+              <a:t>For believers only, by immersion: an act of obedience and public confession that follows salvation.</a:t>
             </a:r>
           </a:p>
           <a:p>
             <a:pPr>
               <a:spcAft>
-                <a:spcPts val="1800"/>
+                <a:spcPts val="1200"/>
               </a:spcAft>
             </a:pPr>
             <a:r>
-              <a:rPr sz="2800" b="1" i="0">
+              <a:rPr sz="2000" b="1" i="0">
                 <a:solidFill>
                   <a:srgbClr val="2E5E8C"/>
                 </a:solidFill>
               </a:rPr>
-              <a:t>2.  </a:t>
-            </a:r>
-            <a:r>
-              <a:rPr sz="2800" b="0" i="0">
+              <a:t>Methodist and Wesleyan:  </a:t>
+            </a:r>
+            <a:r>
+              <a:rPr sz="2000" b="0" i="0">
                 <a:solidFill>
                   <a:srgbClr val="222B36"/>
                 </a:solidFill>
               </a:rPr>
-              <a:t>Each tradition points to particular verses. Why do sincere Christians reading the same Bible reach different conclusions about baptism?</a:t>
+              <a:t>A sacrament and means of grace, for believers and their children; usually by pouring or sprinkling.</a:t>
             </a:r>
           </a:p>
           <a:p>
             <a:pPr>
               <a:spcAft>
-                <a:spcPts val="1800"/>
+                <a:spcPts val="1200"/>
               </a:spcAft>
             </a:pPr>
             <a:r>
-              <a:rPr sz="2800" b="1" i="0">
+              <a:rPr sz="2000" b="1" i="0">
                 <a:solidFill>
                   <a:srgbClr val="2E5E8C"/>
                 </a:solidFill>
               </a:rPr>
-              <a:t>3.  </a:t>
-            </a:r>
-            <a:r>
-              <a:rPr sz="2800" b="0" i="0">
+              <a:t>Presbyterian and Reformed:  </a:t>
+            </a:r>
+            <a:r>
+              <a:rPr sz="2000" b="0" i="0">
                 <a:solidFill>
                   <a:srgbClr val="222B36"/>
                 </a:solidFill>
               </a:rPr>
-              <a:t>How can we hold our own convictions about baptism while showing love to Christians who practise it differently?</a:t>
+              <a:t>A sign and seal of God's covenant, for believers and their children, as circumcision was before.</a:t>
+            </a:r>
+          </a:p>
+          <a:p>
+            <a:pPr>
+              <a:spcAft>
+                <a:spcPts val="1200"/>
+              </a:spcAft>
+            </a:pPr>
+            <a:r>
+              <a:rPr sz="2000" b="1" i="0">
+                <a:solidFill>
+                  <a:srgbClr val="2E5E8C"/>
+                </a:solidFill>
+              </a:rPr>
+              <a:t>Lutheran:  </a:t>
+            </a:r>
+            <a:r>
+              <a:rPr sz="2000" b="0" i="0">
+                <a:solidFill>
+                  <a:srgbClr val="222B36"/>
+                </a:solidFill>
+              </a:rPr>
+              <a:t>A means of grace through which God gives forgiveness and salvation; infants are baptized.</a:t>
+            </a:r>
+          </a:p>
+          <a:p>
+            <a:pPr>
+              <a:spcAft>
+                <a:spcPts val="1200"/>
+              </a:spcAft>
+            </a:pPr>
+            <a:r>
+              <a:rPr sz="2000" b="1" i="0">
+                <a:solidFill>
+                  <a:srgbClr val="2E5E8C"/>
+                </a:solidFill>
+              </a:rPr>
+              <a:t>Pentecostal and Charismatic:  </a:t>
+            </a:r>
+            <a:r>
+              <a:rPr sz="2000" b="0" i="0">
+                <a:solidFill>
+                  <a:srgbClr val="222B36"/>
+                </a:solidFill>
+              </a:rPr>
+              <a:t>For believers only, by immersion, as Baptists hold; with a distinct baptism in the Holy Spirit.</a:t>
             </a:r>
           </a:p>
         </p:txBody>
@@ -5151,6 +5268,235 @@
 </file>
 
 <file path=ppt/slides/slide8.xml><?xml version="1.0" encoding="utf-8"?>
+<p:sld xmlns:a="http://schemas.openxmlformats.org/drawingml/2006/main" xmlns:p="http://schemas.openxmlformats.org/presentationml/2006/main" xmlns:r="http://schemas.openxmlformats.org/officeDocument/2006/relationships">
+  <p:cSld>
+    <p:spTree>
+      <p:nvGrpSpPr>
+        <p:cNvPr id="1" name=""/>
+        <p:cNvGrpSpPr/>
+        <p:nvPr/>
+      </p:nvGrpSpPr>
+      <p:grpSpPr/>
+      <p:sp>
+        <p:nvSpPr>
+          <p:cNvPr id="2" name="Rectangle 1"/>
+          <p:cNvSpPr/>
+          <p:nvPr/>
+        </p:nvSpPr>
+        <p:spPr>
+          <a:xfrm>
+            <a:off x="0" y="0"/>
+            <a:ext cx="12191695" cy="109728"/>
+          </a:xfrm>
+          <a:prstGeom prst="rect">
+            <a:avLst/>
+          </a:prstGeom>
+          <a:solidFill>
+            <a:srgbClr val="2E5E8C"/>
+          </a:solidFill>
+          <a:ln>
+            <a:noFill/>
+          </a:ln>
+        </p:spPr>
+        <p:style>
+          <a:lnRef idx="1">
+            <a:schemeClr val="accent1"/>
+          </a:lnRef>
+          <a:fillRef idx="3">
+            <a:schemeClr val="accent1"/>
+          </a:fillRef>
+          <a:effectRef idx="2">
+            <a:schemeClr val="accent1"/>
+          </a:effectRef>
+          <a:fontRef idx="minor">
+            <a:schemeClr val="lt1"/>
+          </a:fontRef>
+        </p:style>
+        <p:txBody>
+          <a:bodyPr rtlCol="0" anchor="ctr"/>
+          <a:lstStyle/>
+          <a:p>
+            <a:pPr algn="ctr"/>
+          </a:p>
+        </p:txBody>
+      </p:sp>
+      <p:sp>
+        <p:nvSpPr>
+          <p:cNvPr id="3" name="TextBox 2"/>
+          <p:cNvSpPr txBox="1"/>
+          <p:nvPr/>
+        </p:nvSpPr>
+        <p:spPr>
+          <a:xfrm>
+            <a:off x="640080" y="411480"/>
+            <a:ext cx="10881360" cy="914400"/>
+          </a:xfrm>
+          <a:prstGeom prst="rect">
+            <a:avLst/>
+          </a:prstGeom>
+          <a:noFill/>
+        </p:spPr>
+        <p:txBody>
+          <a:bodyPr wrap="square">
+            <a:spAutoFit/>
+          </a:bodyPr>
+          <a:lstStyle/>
+          <a:p>
+            <a:pPr>
+              <a:spcAft>
+                <a:spcPts val="1000"/>
+              </a:spcAft>
+            </a:pPr>
+            <a:r>
+              <a:rPr sz="3200" b="1" i="0">
+                <a:solidFill>
+                  <a:srgbClr val="222B36"/>
+                </a:solidFill>
+              </a:rPr>
+              <a:t>Discuss</a:t>
+            </a:r>
+          </a:p>
+        </p:txBody>
+      </p:sp>
+      <p:sp>
+        <p:nvSpPr>
+          <p:cNvPr id="4" name="TextBox 3"/>
+          <p:cNvSpPr txBox="1"/>
+          <p:nvPr/>
+        </p:nvSpPr>
+        <p:spPr>
+          <a:xfrm>
+            <a:off x="640080" y="6263640"/>
+            <a:ext cx="10881360" cy="365760"/>
+          </a:xfrm>
+          <a:prstGeom prst="rect">
+            <a:avLst/>
+          </a:prstGeom>
+          <a:noFill/>
+        </p:spPr>
+        <p:txBody>
+          <a:bodyPr wrap="square">
+            <a:spAutoFit/>
+          </a:bodyPr>
+          <a:lstStyle/>
+          <a:p>
+            <a:pPr>
+              <a:spcAft>
+                <a:spcPts val="1000"/>
+              </a:spcAft>
+            </a:pPr>
+            <a:r>
+              <a:rPr sz="1200" b="0" i="0">
+                <a:solidFill>
+                  <a:srgbClr val="6B7280"/>
+                </a:solidFill>
+              </a:rPr>
+              <a:t>Baptized into Christ</a:t>
+            </a:r>
+          </a:p>
+        </p:txBody>
+      </p:sp>
+      <p:sp>
+        <p:nvSpPr>
+          <p:cNvPr id="5" name="TextBox 4"/>
+          <p:cNvSpPr txBox="1"/>
+          <p:nvPr/>
+        </p:nvSpPr>
+        <p:spPr>
+          <a:xfrm>
+            <a:off x="640080" y="1554480"/>
+            <a:ext cx="10881360" cy="4572000"/>
+          </a:xfrm>
+          <a:prstGeom prst="rect">
+            <a:avLst/>
+          </a:prstGeom>
+          <a:noFill/>
+        </p:spPr>
+        <p:txBody>
+          <a:bodyPr wrap="square">
+            <a:spAutoFit/>
+          </a:bodyPr>
+          <a:lstStyle/>
+          <a:p>
+            <a:pPr>
+              <a:spcAft>
+                <a:spcPts val="1800"/>
+              </a:spcAft>
+            </a:pPr>
+            <a:r>
+              <a:rPr sz="2800" b="1" i="0">
+                <a:solidFill>
+                  <a:srgbClr val="2E5E8C"/>
+                </a:solidFill>
+              </a:rPr>
+              <a:t>1.  </a:t>
+            </a:r>
+            <a:r>
+              <a:rPr sz="2800" b="0" i="0">
+                <a:solidFill>
+                  <a:srgbClr val="222B36"/>
+                </a:solidFill>
+              </a:rPr>
+              <a:t>What do all Christians agree about baptism, according to today's passages?</a:t>
+            </a:r>
+          </a:p>
+          <a:p>
+            <a:pPr>
+              <a:spcAft>
+                <a:spcPts val="1800"/>
+              </a:spcAft>
+            </a:pPr>
+            <a:r>
+              <a:rPr sz="2800" b="1" i="0">
+                <a:solidFill>
+                  <a:srgbClr val="2E5E8C"/>
+                </a:solidFill>
+              </a:rPr>
+              <a:t>2.  </a:t>
+            </a:r>
+            <a:r>
+              <a:rPr sz="2800" b="0" i="0">
+                <a:solidFill>
+                  <a:srgbClr val="222B36"/>
+                </a:solidFill>
+              </a:rPr>
+              <a:t>Each tradition points to particular verses. Why do sincere Christians reading the same Bible reach different conclusions about baptism?</a:t>
+            </a:r>
+          </a:p>
+          <a:p>
+            <a:pPr>
+              <a:spcAft>
+                <a:spcPts val="1800"/>
+              </a:spcAft>
+            </a:pPr>
+            <a:r>
+              <a:rPr sz="2800" b="1" i="0">
+                <a:solidFill>
+                  <a:srgbClr val="2E5E8C"/>
+                </a:solidFill>
+              </a:rPr>
+              <a:t>3.  </a:t>
+            </a:r>
+            <a:r>
+              <a:rPr sz="2800" b="0" i="0">
+                <a:solidFill>
+                  <a:srgbClr val="222B36"/>
+                </a:solidFill>
+              </a:rPr>
+              <a:t>How can we hold our own convictions about baptism while showing love to Christians who practise it differently?</a:t>
+            </a:r>
+          </a:p>
+        </p:txBody>
+      </p:sp>
+    </p:spTree>
+  </p:cSld>
+  <p:clrMapOvr>
+    <a:masterClrMapping/>
+  </p:clrMapOvr>
+</p:sld>
+</file>
+
+<file path=ppt/slides/slide9.xml><?xml version="1.0" encoding="utf-8"?>
 <p:sld xmlns:a="http://schemas.openxmlformats.org/drawingml/2006/main" xmlns:p="http://schemas.openxmlformats.org/presentationml/2006/main" xmlns:r="http://schemas.openxmlformats.org/officeDocument/2006/relationships">
   <p:cSld>
     <p:spTree>

</xml_diff>